<commit_message>
fix: remove top institutional banner and bottom emblem from Slide 1 and Slide 20
</commit_message>
<xml_diff>
--- a/CAMPUS_EVENTS_PRESENTATION.pptx
+++ b/CAMPUS_EVENTS_PRESENTATION.pptx
@@ -3150,46 +3150,22 @@
           </a:p>
         </p:txBody>
       </p:sp>
-      <p:pic>
-        <p:nvPicPr>
-          <p:cNvPr id="3" name="Picture 2" descr="Image7.jpg"/>
-          <p:cNvPicPr>
-            <a:picLocks noChangeAspect="1"/>
-          </p:cNvPicPr>
-          <p:nvPr/>
-        </p:nvPicPr>
-        <p:blipFill>
-          <a:blip r:embed="rId2"/>
-          <a:stretch>
-            <a:fillRect/>
-          </a:stretch>
-        </p:blipFill>
-        <p:spPr>
-          <a:xfrm>
-            <a:off x="1371600" y="365760"/>
-            <a:ext cx="9448495" cy="822960"/>
-          </a:xfrm>
-          <a:prstGeom prst="rect">
-            <a:avLst/>
-          </a:prstGeom>
-        </p:spPr>
-      </p:pic>
-      <p:sp>
-        <p:nvSpPr>
-          <p:cNvPr id="4" name="Rounded Rectangle 3"/>
+      <p:sp>
+        <p:nvSpPr>
+          <p:cNvPr id="3" name="Rounded Rectangle 2"/>
           <p:cNvSpPr/>
           <p:nvPr/>
         </p:nvSpPr>
         <p:spPr>
           <a:xfrm>
-            <a:off x="1097280" y="1417320"/>
-            <a:ext cx="9997135" cy="2926080"/>
+            <a:off x="2286000" y="548640"/>
+            <a:ext cx="7619695" cy="384048"/>
           </a:xfrm>
           <a:prstGeom prst="roundRect">
             <a:avLst/>
           </a:prstGeom>
           <a:solidFill>
-            <a:srgbClr val="131C2E"/>
+            <a:srgbClr val="18243A"/>
           </a:solidFill>
           <a:ln w="12700">
             <a:solidFill>
@@ -3215,6 +3191,61 @@
           <a:bodyPr rtlCol="0" anchor="ctr"/>
           <a:lstStyle/>
           <a:p>
+            <a:pPr algn="ctr">
+              <a:defRPr sz="1000" b="1">
+                <a:solidFill>
+                  <a:srgbClr val="6366F1"/>
+                </a:solidFill>
+                <a:latin typeface="Segoe UI"/>
+              </a:defRPr>
+            </a:pPr>
+            <a:r>
+              <a:t>JAWAHARLAL COLLEGE OF ENGINEERING AND TECHNOLOGY (JCET AUTONOMOUS)</a:t>
+            </a:r>
+          </a:p>
+        </p:txBody>
+      </p:sp>
+      <p:sp>
+        <p:nvSpPr>
+          <p:cNvPr id="4" name="Rounded Rectangle 3"/>
+          <p:cNvSpPr/>
+          <p:nvPr/>
+        </p:nvSpPr>
+        <p:spPr>
+          <a:xfrm>
+            <a:off x="1097280" y="1188720"/>
+            <a:ext cx="9997135" cy="3108960"/>
+          </a:xfrm>
+          <a:prstGeom prst="roundRect">
+            <a:avLst/>
+          </a:prstGeom>
+          <a:solidFill>
+            <a:srgbClr val="131C2E"/>
+          </a:solidFill>
+          <a:ln w="12700">
+            <a:solidFill>
+              <a:srgbClr val="06B6D4"/>
+            </a:solidFill>
+          </a:ln>
+        </p:spPr>
+        <p:style>
+          <a:lnRef idx="1">
+            <a:schemeClr val="accent1"/>
+          </a:lnRef>
+          <a:fillRef idx="3">
+            <a:schemeClr val="accent1"/>
+          </a:fillRef>
+          <a:effectRef idx="2">
+            <a:schemeClr val="accent1"/>
+          </a:effectRef>
+          <a:fontRef idx="minor">
+            <a:schemeClr val="lt1"/>
+          </a:fontRef>
+        </p:style>
+        <p:txBody>
+          <a:bodyPr rtlCol="0" anchor="ctr"/>
+          <a:lstStyle/>
+          <a:p>
             <a:pPr algn="ctr"/>
           </a:p>
         </p:txBody>
@@ -3227,8 +3258,8 @@
         </p:nvSpPr>
         <p:spPr>
           <a:xfrm>
-            <a:off x="1371600" y="1600200"/>
-            <a:ext cx="9448495" cy="2560320"/>
+            <a:off x="1371600" y="1371600"/>
+            <a:ext cx="9448495" cy="2743200"/>
           </a:xfrm>
           <a:prstGeom prst="rect">
             <a:avLst/>
@@ -3243,25 +3274,25 @@
           <a:p>
             <a:pPr>
               <a:spcAft>
+                <a:spcPts val="800"/>
+              </a:spcAft>
+              <a:defRPr sz="1100" b="1">
+                <a:solidFill>
+                  <a:srgbClr val="06B6D4"/>
+                </a:solidFill>
+                <a:latin typeface="Segoe UI"/>
+              </a:defRPr>
+            </a:pPr>
+            <a:r>
+              <a:t>PROJECT PRESENTATION  |  HYBRID APP DEVELOPMENT (25CCHADT305)</a:t>
+            </a:r>
+          </a:p>
+          <a:p>
+            <a:pPr>
+              <a:spcAft>
                 <a:spcPts val="600"/>
               </a:spcAft>
-              <a:defRPr sz="1100" b="1">
-                <a:solidFill>
-                  <a:srgbClr val="06B6D4"/>
-                </a:solidFill>
-                <a:latin typeface="Segoe UI"/>
-              </a:defRPr>
-            </a:pPr>
-            <a:r>
-              <a:t>PROJECT PRESENTATION  |  HYBRID APP DEVELOPMENT (25CCHADT305)</a:t>
-            </a:r>
-          </a:p>
-          <a:p>
-            <a:pPr>
-              <a:spcAft>
-                <a:spcPts val="400"/>
-              </a:spcAft>
-              <a:defRPr sz="3600" b="1">
+              <a:defRPr sz="4000" b="1">
                 <a:solidFill>
                   <a:srgbClr val="F8FAFC"/>
                 </a:solidFill>
@@ -3274,7 +3305,7 @@
           </a:p>
           <a:p>
             <a:pPr>
-              <a:defRPr sz="1300">
+              <a:defRPr sz="1350">
                 <a:solidFill>
                   <a:srgbClr val="94A3B8"/>
                 </a:solidFill>
@@ -3296,7 +3327,7 @@
         <p:spPr>
           <a:xfrm>
             <a:off x="1097280" y="4526280"/>
-            <a:ext cx="4892040" cy="1737360"/>
+            <a:ext cx="4892040" cy="1874519"/>
           </a:xfrm>
           <a:prstGeom prst="roundRect">
             <a:avLst/>
@@ -3341,7 +3372,7 @@
         <p:spPr>
           <a:xfrm>
             <a:off x="1280160" y="4709160"/>
-            <a:ext cx="4526280" cy="1371600"/>
+            <a:ext cx="4526280" cy="1508759"/>
           </a:xfrm>
           <a:prstGeom prst="rect">
             <a:avLst/>
@@ -3441,7 +3472,7 @@
         <p:spPr>
           <a:xfrm>
             <a:off x="6199632" y="4526280"/>
-            <a:ext cx="4892040" cy="1737360"/>
+            <a:ext cx="4892040" cy="1874519"/>
           </a:xfrm>
           <a:prstGeom prst="roundRect">
             <a:avLst/>
@@ -3486,7 +3517,7 @@
         <p:spPr>
           <a:xfrm>
             <a:off x="6382512" y="4709160"/>
-            <a:ext cx="4526280" cy="1371600"/>
+            <a:ext cx="4526280" cy="1508759"/>
           </a:xfrm>
           <a:prstGeom prst="rect">
             <a:avLst/>
@@ -9448,40 +9479,16 @@
           </a:p>
         </p:txBody>
       </p:sp>
-      <p:pic>
-        <p:nvPicPr>
-          <p:cNvPr id="3" name="Picture 2" descr="Image7.jpg"/>
-          <p:cNvPicPr>
-            <a:picLocks noChangeAspect="1"/>
-          </p:cNvPicPr>
-          <p:nvPr/>
-        </p:nvPicPr>
-        <p:blipFill>
-          <a:blip r:embed="rId2"/>
-          <a:stretch>
-            <a:fillRect/>
-          </a:stretch>
-        </p:blipFill>
-        <p:spPr>
-          <a:xfrm>
-            <a:off x="1371600" y="365760"/>
-            <a:ext cx="9448495" cy="822960"/>
-          </a:xfrm>
-          <a:prstGeom prst="rect">
-            <a:avLst/>
-          </a:prstGeom>
-        </p:spPr>
-      </p:pic>
-      <p:sp>
-        <p:nvSpPr>
-          <p:cNvPr id="4" name="Rounded Rectangle 3"/>
+      <p:sp>
+        <p:nvSpPr>
+          <p:cNvPr id="3" name="Rounded Rectangle 2"/>
           <p:cNvSpPr/>
           <p:nvPr/>
         </p:nvSpPr>
         <p:spPr>
           <a:xfrm>
-            <a:off x="1371600" y="1463040"/>
-            <a:ext cx="9448495" cy="3931920"/>
+            <a:off x="1371600" y="914400"/>
+            <a:ext cx="9448495" cy="5029200"/>
           </a:xfrm>
           <a:prstGeom prst="roundRect">
             <a:avLst/>
@@ -9519,14 +9526,14 @@
       </p:sp>
       <p:sp>
         <p:nvSpPr>
-          <p:cNvPr id="5" name="TextBox 4"/>
+          <p:cNvPr id="4" name="TextBox 3"/>
           <p:cNvSpPr txBox="1"/>
           <p:nvPr/>
         </p:nvSpPr>
         <p:spPr>
           <a:xfrm>
-            <a:off x="1645920" y="1645920"/>
-            <a:ext cx="8899855" cy="3474720"/>
+            <a:off x="1645920" y="1188720"/>
+            <a:ext cx="8899855" cy="4480560"/>
           </a:xfrm>
           <a:prstGeom prst="rect">
             <a:avLst/>
@@ -9541,86 +9548,86 @@
           <a:p>
             <a:pPr algn="ctr">
               <a:spcAft>
+                <a:spcPts val="800"/>
+              </a:spcAft>
+              <a:defRPr sz="4400" b="1">
+                <a:solidFill>
+                  <a:srgbClr val="06B6D4"/>
+                </a:solidFill>
+                <a:latin typeface="Segoe UI"/>
+              </a:defRPr>
+            </a:pPr>
+            <a:r>
+              <a:t>THANK YOU!</a:t>
+            </a:r>
+          </a:p>
+          <a:p>
+            <a:pPr algn="ctr">
+              <a:spcAft>
+                <a:spcPts val="2400"/>
+              </a:spcAft>
+              <a:defRPr sz="1800" b="1">
+                <a:solidFill>
+                  <a:srgbClr val="F8FAFC"/>
+                </a:solidFill>
+                <a:latin typeface="Segoe UI"/>
+              </a:defRPr>
+            </a:pPr>
+            <a:r>
+              <a:t>Open for Questions &amp; Evaluation Committee Discussion</a:t>
+            </a:r>
+          </a:p>
+          <a:p>
+            <a:pPr algn="ctr">
+              <a:spcAft>
+                <a:spcPts val="800"/>
+              </a:spcAft>
+              <a:defRPr sz="1300" b="1">
+                <a:solidFill>
+                  <a:srgbClr val="6366F1"/>
+                </a:solidFill>
+                <a:latin typeface="Segoe UI"/>
+              </a:defRPr>
+            </a:pPr>
+            <a:r>
+              <a:t>CAMPUS EVENTS  |  HYBRID APP DEVELOPMENT (25CCHADT305)</a:t>
+            </a:r>
+          </a:p>
+          <a:p>
+            <a:pPr algn="ctr">
+              <a:spcAft>
                 <a:spcPts val="600"/>
               </a:spcAft>
-              <a:defRPr sz="3600" b="1">
-                <a:solidFill>
-                  <a:srgbClr val="06B6D4"/>
-                </a:solidFill>
-                <a:latin typeface="Segoe UI"/>
-              </a:defRPr>
-            </a:pPr>
-            <a:r>
-              <a:t>THANK YOU!</a:t>
+              <a:defRPr sz="1300">
+                <a:solidFill>
+                  <a:srgbClr val="F8FAFC"/>
+                </a:solidFill>
+                <a:latin typeface="Segoe UI"/>
+              </a:defRPr>
+            </a:pPr>
+            <a:r>
+              <a:t>Candidate: ARJUN P KOLIKKAL (JCE25CC019)  |  B.Tech in CSE - CYBER SECURITY</a:t>
             </a:r>
           </a:p>
           <a:p>
             <a:pPr algn="ctr">
               <a:spcAft>
-                <a:spcPts val="1800"/>
-              </a:spcAft>
-              <a:defRPr sz="1600" b="1">
-                <a:solidFill>
-                  <a:srgbClr val="F8FAFC"/>
-                </a:solidFill>
-                <a:latin typeface="Segoe UI"/>
-              </a:defRPr>
-            </a:pPr>
-            <a:r>
-              <a:t>Open for Questions &amp; Evaluation Committee Discussion</a:t>
+                <a:spcPts val="600"/>
+              </a:spcAft>
+              <a:defRPr sz="1200">
+                <a:solidFill>
+                  <a:srgbClr val="94A3B8"/>
+                </a:solidFill>
+                <a:latin typeface="Segoe UI"/>
+              </a:defRPr>
+            </a:pPr>
+            <a:r>
+              <a:t>Guided by: Prof. Dr. R. SATHEESH KUMAR (Professor and HoD, CSE)</a:t>
             </a:r>
           </a:p>
           <a:p>
             <a:pPr algn="ctr">
-              <a:spcAft>
-                <a:spcPts val="600"/>
-              </a:spcAft>
-              <a:defRPr sz="1200" b="1">
-                <a:solidFill>
-                  <a:srgbClr val="6366F1"/>
-                </a:solidFill>
-                <a:latin typeface="Segoe UI"/>
-              </a:defRPr>
-            </a:pPr>
-            <a:r>
-              <a:t>CAMPUS EVENTS  |  HYBRID APP DEVELOPMENT (25CCHADT305)</a:t>
-            </a:r>
-          </a:p>
-          <a:p>
-            <a:pPr algn="ctr">
-              <a:spcAft>
-                <a:spcPts val="400"/>
-              </a:spcAft>
-              <a:defRPr sz="1200">
-                <a:solidFill>
-                  <a:srgbClr val="94A3B8"/>
-                </a:solidFill>
-                <a:latin typeface="Segoe UI"/>
-              </a:defRPr>
-            </a:pPr>
-            <a:r>
-              <a:t>Candidate: ARJUN P KOLIKKAL (JCE25CC019)  |  B.Tech in CSE - CYBER SECURITY</a:t>
-            </a:r>
-          </a:p>
-          <a:p>
-            <a:pPr algn="ctr">
-              <a:spcAft>
-                <a:spcPts val="400"/>
-              </a:spcAft>
-              <a:defRPr sz="1200">
-                <a:solidFill>
-                  <a:srgbClr val="94A3B8"/>
-                </a:solidFill>
-                <a:latin typeface="Segoe UI"/>
-              </a:defRPr>
-            </a:pPr>
-            <a:r>
-              <a:t>Guided by: Prof. Dr. R. SATHEESH KUMAR (Professor and HoD)</a:t>
-            </a:r>
-          </a:p>
-          <a:p>
-            <a:pPr algn="ctr">
-              <a:defRPr sz="1100">
+              <a:defRPr sz="1150">
                 <a:solidFill>
                   <a:srgbClr val="10B981"/>
                 </a:solidFill>
@@ -9628,35 +9635,11 @@
               </a:defRPr>
             </a:pPr>
             <a:r>
-              <a:t>Jawaharlal College of Engineering and Technology (JCET Autonomous)  |  Academic Year 2026–2027</a:t>
-            </a:r>
-          </a:p>
-        </p:txBody>
-      </p:sp>
-      <p:pic>
-        <p:nvPicPr>
-          <p:cNvPr id="6" name="Picture 5" descr="Image20.jpg"/>
-          <p:cNvPicPr>
-            <a:picLocks noChangeAspect="1"/>
-          </p:cNvPicPr>
-          <p:nvPr/>
-        </p:nvPicPr>
-        <p:blipFill>
-          <a:blip r:embed="rId3"/>
-          <a:stretch>
-            <a:fillRect/>
-          </a:stretch>
-        </p:blipFill>
-        <p:spPr>
-          <a:xfrm>
-            <a:off x="5638190" y="5577840"/>
-            <a:ext cx="914400" cy="777240"/>
-          </a:xfrm>
-          <a:prstGeom prst="rect">
-            <a:avLst/>
-          </a:prstGeom>
-        </p:spPr>
-      </p:pic>
+              <a:t>Jawaharlal College of Engineering and Technology (Autonomous)  |  Academic Year 2026–2027</a:t>
+            </a:r>
+          </a:p>
+        </p:txBody>
+      </p:sp>
     </p:spTree>
   </p:cSld>
   <p:clrMapOvr>

</xml_diff>

<commit_message>
chore(report): update Head of Department (HoD) to Prof. Manoj M
</commit_message>
<xml_diff>
--- a/CAMPUS_EVENTS_PRESENTATION.pptx
+++ b/CAMPUS_EVENTS_PRESENTATION.pptx
@@ -3555,7 +3555,7 @@
               </a:defRPr>
             </a:pPr>
             <a:r>
-              <a:t>Prof. Dr. R. SATHEESH KUMAR</a:t>
+              <a:t>Prof. Manoj M</a:t>
             </a:r>
           </a:p>
           <a:p>
@@ -9622,7 +9622,7 @@
               </a:defRPr>
             </a:pPr>
             <a:r>
-              <a:t>Guided by: Prof. Dr. R. SATHEESH KUMAR (Professor and HoD, CSE)</a:t>
+              <a:t>Guided by: Ms.Ashitha.C (Project Guide)  |  HoD: Prof. Manoj M</a:t>
             </a:r>
           </a:p>
           <a:p>

</xml_diff>